<commit_message>
Data: collection run 2026-09-20
</commit_message>
<xml_diff>
--- a/paper/presentation.pptx
+++ b/paper/presentation.pptx
@@ -2982,7 +2982,7 @@
       </p:sp>
       <p:pic>
         <p:nvPicPr>
-          <p:cNvPr id="3" name="Image 0" descr="/home/user/modern-labor-market-data-submission/paper/figures/fig1_funnel.png">    </p:cNvPr>
+          <p:cNvPr id="3" name="Image 0" descr="/home/runner/work/Modern-Labor-Market-Data-Submission/Modern-Labor-Market-Data-Submission/paper/figures/fig1_funnel.png">    </p:cNvPr>
           <p:cNvPicPr>
             <a:picLocks noChangeAspect="1"/>
           </p:cNvPicPr>
@@ -3041,7 +3041,7 @@
                 <a:ea typeface="Calibri" pitchFamily="34" charset="-122"/>
                 <a:cs typeface="Calibri" pitchFamily="34" charset="-120"/>
               </a:rPr>
-              <a:t>Retrieved: 7</a:t>
+              <a:t>Retrieved: 53</a:t>
             </a:r>
             <a:endParaRPr lang="en-US" sz="1400" dirty="0"/>
           </a:p>

</xml_diff>

<commit_message>
Regenerate deliverables from run 32's committed data so the 30 September run can start
Run 33 (the hand dispatch of the 30 September run) failed its pre-collection
test gate in 40 seconds and collected nothing: run 32, the 29 September cron
that fired 6.5 hours late, committed data/ at N = 536, while the paper and
summary, regenerated only locally by design, still said 531. The
consistency suite correctly refused to collect on an inconsistent
repository. Deliverables regenerated from the committed (unaudited) data;
audit round 12 audits and regenerates them again. ALL SUITES PASSED;
consistency 30/30.

Co-Authored-By: Claude Opus 5.5 <noreply@anthropic.com>
Claude-Session: https://claude.ai/code/session_017mQEyC1nHmW1hiYpw1zSZp
</commit_message>
<xml_diff>
--- a/paper/presentation.pptx
+++ b/paper/presentation.pptx
@@ -509,7 +509,7 @@
           <a:p>
             <a:r>
               <a:rPr lang="en-US" dirty="0"/>
-              <a:t>Current estimation sample: 531 postings with a disclosed pay range. The dependent variable is the log of the midpoint of the employer-stated range, annualized.</a:t>
+              <a:t>Current estimation sample: 536 postings with a disclosed pay range. The dependent variable is the log of the midpoint of the employer-stated range, annualized.</a:t>
             </a:r>
             <a:endParaRPr lang="en-US" dirty="0"/>
           </a:p>
@@ -2617,7 +2617,7 @@
                 <a:ea typeface="Calibri" pitchFamily="34" charset="-122"/>
                 <a:cs typeface="Calibri" pitchFamily="34" charset="-120"/>
               </a:rPr>
-              <a:t>92%</a:t>
+              <a:t>91%</a:t>
             </a:r>
             <a:endParaRPr lang="en-US" sz="4000" dirty="0"/>
           </a:p>
@@ -2656,7 +2656,7 @@
                 <a:ea typeface="Calibri" pitchFamily="34" charset="-122"/>
                 <a:cs typeface="Calibri" pitchFamily="34" charset="-120"/>
               </a:rPr>
-              <a:t>disclose (n=438)</a:t>
+              <a:t>disclose (n=443)</a:t>
             </a:r>
             <a:endParaRPr lang="en-US" sz="1200" dirty="0"/>
           </a:p>
@@ -2761,7 +2761,7 @@
                 <a:ea typeface="Calibri" pitchFamily="34" charset="-122"/>
                 <a:cs typeface="Calibri" pitchFamily="34" charset="-120"/>
               </a:rPr>
-              <a:t>disclose without one (n=272)</a:t>
+              <a:t>disclose without one (n=277)</a:t>
             </a:r>
             <a:endParaRPr lang="en-US" sz="1200" dirty="0"/>
           </a:p>
@@ -3041,7 +3041,7 @@
                 <a:ea typeface="Calibri" pitchFamily="34" charset="-122"/>
                 <a:cs typeface="Calibri" pitchFamily="34" charset="-120"/>
               </a:rPr>
-              <a:t>Retrieved: 12441</a:t>
+              <a:t>Retrieved: 12680</a:t>
             </a:r>
             <a:endParaRPr lang="en-US" sz="1400" dirty="0"/>
           </a:p>
@@ -3062,7 +3062,7 @@
                 <a:ea typeface="Calibri" pitchFamily="34" charset="-122"/>
                 <a:cs typeface="Calibri" pitchFamily="34" charset="-120"/>
               </a:rPr>
-              <a:t>Passed screens: 2923</a:t>
+              <a:t>Passed screens: 3081</a:t>
             </a:r>
             <a:endParaRPr lang="en-US" sz="1400" dirty="0"/>
           </a:p>
@@ -3083,7 +3083,7 @@
                 <a:ea typeface="Calibri" pitchFamily="34" charset="-122"/>
                 <a:cs typeface="Calibri" pitchFamily="34" charset="-120"/>
               </a:rPr>
-              <a:t>Located in the US: 2183</a:t>
+              <a:t>Located in the US: 2338</a:t>
             </a:r>
             <a:endParaRPr lang="en-US" sz="1400" dirty="0"/>
           </a:p>
@@ -3104,7 +3104,7 @@
                 <a:ea typeface="Calibri" pitchFamily="34" charset="-122"/>
                 <a:cs typeface="Calibri" pitchFamily="34" charset="-120"/>
               </a:rPr>
-              <a:t>Unique postings: 710</a:t>
+              <a:t>Unique postings: 720</a:t>
             </a:r>
             <a:endParaRPr lang="en-US" sz="1400" dirty="0"/>
           </a:p>
@@ -3125,7 +3125,7 @@
                 <a:ea typeface="Calibri" pitchFamily="34" charset="-122"/>
                 <a:cs typeface="Calibri" pitchFamily="34" charset="-120"/>
               </a:rPr>
-              <a:t>Pay disclosed: 531</a:t>
+              <a:t>Pay disclosed: 536</a:t>
             </a:r>
             <a:endParaRPr lang="en-US" sz="1400" dirty="0"/>
           </a:p>
@@ -3409,7 +3409,7 @@
                 <a:ea typeface="Calibri" pitchFamily="34" charset="-122"/>
                 <a:cs typeface="Calibri" pitchFamily="34" charset="-120"/>
               </a:rPr>
-              <a:t>531</a:t>
+              <a:t>536</a:t>
             </a:r>
             <a:endParaRPr lang="en-US" sz="4000" dirty="0"/>
           </a:p>
@@ -3623,7 +3623,7 @@
                 <a:ea typeface="Calibri" pitchFamily="34" charset="-122"/>
                 <a:cs typeface="Calibri" pitchFamily="34" charset="-120"/>
               </a:rPr>
-              <a:t>Within disclosed pay, seniority, required experience, a stated cloud skill, a Northeast location, a West location, stating an experience minimum and a STEM degree are the only attributes distinguishable from zero — stating an experience minimum, a STEM degree and a West location only narrowly, so read them as tentative; a Northeast location and a West location do not survive price adjustment</a:t>
+              <a:t>Within disclosed pay, seniority, required experience, a stated cloud skill, a West location, a Northeast location, stating an experience minimum and a STEM degree are the only attributes distinguishable from zero — stating an experience minimum, a STEM degree and a West location only narrowly, so read them as tentative; a Northeast location and a West location do not survive price adjustment</a:t>
             </a:r>
             <a:endParaRPr lang="en-US" sz="1500" dirty="0"/>
           </a:p>
@@ -4272,7 +4272,7 @@
                 <a:ea typeface="Calibri" pitchFamily="34" charset="-122"/>
                 <a:cs typeface="Calibri" pitchFamily="34" charset="-120"/>
               </a:rPr>
-              <a:t>Clustered errors cover at 92% against a nominal 95%. Significance is read off a wild cluster bootstrap, which leaves 7 predictor(s) standing: seniority, required experience, a stated cloud skill, a Northeast location, a West location, stating an experience minimum, a STEM degree.</a:t>
+              <a:t>Clustered errors cover at 92% against a nominal 95%. Significance is read off a wild cluster bootstrap, which leaves 7 predictor(s) standing: seniority, required experience, a stated cloud skill, a West location, a Northeast location, stating an experience minimum, a STEM degree.</a:t>
             </a:r>
             <a:endParaRPr lang="en-US" sz="1300" dirty="0"/>
           </a:p>

</xml_diff>